<commit_message>
Updated version with disclaimer added to it.
</commit_message>
<xml_diff>
--- a/LIDL_Research.pptx
+++ b/LIDL_Research.pptx
@@ -37111,6 +37111,60 @@
               <a:rPr lang="en-IE" dirty="0"/>
               <a:t>Date: XY, XYWZ</a:t>
             </a:r>
+          </a:p>
+        </p:txBody>
+      </p:sp>
+      <p:sp>
+        <p:nvSpPr>
+          <p:cNvPr id="7" name="TextBox 6">
+            <a:extLst>
+              <a:ext uri="{FF2B5EF4-FFF2-40B4-BE49-F238E27FC236}">
+                <a16:creationId xmlns:a16="http://schemas.microsoft.com/office/drawing/2014/main" id="{1372FEE9-FDDE-C37E-FE6A-F3BCBCFA60AE}"/>
+              </a:ext>
+            </a:extLst>
+          </p:cNvPr>
+          <p:cNvSpPr txBox="1"/>
+          <p:nvPr/>
+        </p:nvSpPr>
+        <p:spPr bwMode="gray">
+          <a:xfrm>
+            <a:off x="263352" y="620688"/>
+            <a:ext cx="0" cy="0"/>
+          </a:xfrm>
+          <a:prstGeom prst="rect">
+            <a:avLst/>
+          </a:prstGeom>
+          <a:noFill/>
+        </p:spPr>
+        <p:txBody>
+          <a:bodyPr wrap="none" lIns="0" tIns="0" rIns="0" bIns="0" rtlCol="0">
+            <a:noAutofit/>
+          </a:bodyPr>
+          <a:lstStyle/>
+          <a:p>
+            <a:r>
+              <a:rPr lang="en-US" dirty="0">
+                <a:solidFill>
+                  <a:srgbClr val="FFFFFF"/>
+                </a:solidFill>
+              </a:rPr>
+              <a:t>Disclaimer: This presentation contains reconstructed project examples for portfolio purposes. </a:t>
+            </a:r>
+          </a:p>
+          <a:p>
+            <a:r>
+              <a:rPr lang="en-US" dirty="0">
+                <a:solidFill>
+                  <a:srgbClr val="FFFFFF"/>
+                </a:solidFill>
+              </a:rPr>
+              <a:t>No confidential client data, proprietary insights, or sensitive materials are included.</a:t>
+            </a:r>
+            <a:endParaRPr lang="en-IN" dirty="0">
+              <a:solidFill>
+                <a:srgbClr val="FFFFFF"/>
+              </a:solidFill>
+            </a:endParaRPr>
           </a:p>
         </p:txBody>
       </p:sp>
@@ -57838,15 +57892,6 @@
 </file>
 
 <file path=customXml/item2.xml><?xml version="1.0" encoding="utf-8"?>
-<?mso-contentType ?>
-<FormTemplates xmlns="http://schemas.microsoft.com/sharepoint/v3/contenttype/forms">
-  <Display>DocumentLibraryForm</Display>
-  <Edit>DocumentLibraryForm</Edit>
-  <New>DocumentLibraryForm</New>
-</FormTemplates>
-</file>
-
-<file path=customXml/item3.xml><?xml version="1.0" encoding="utf-8"?>
 <ct:contentTypeSchema xmlns:ct="http://schemas.microsoft.com/office/2006/metadata/contentType" xmlns:ma="http://schemas.microsoft.com/office/2006/metadata/properties/metaAttributes" ct:_="" ma:_="" ma:contentTypeName="Dokument" ma:contentTypeID="0x0101008772E77FE3346A49873FAAC870391BD1" ma:contentTypeVersion="2" ma:contentTypeDescription="Ein neues Dokument erstellen." ma:contentTypeScope="" ma:versionID="3d6895ab14f3bae7792d1ee7a973e519">
   <xsd:schema xmlns:xsd="http://www.w3.org/2001/XMLSchema" xmlns:xs="http://www.w3.org/2001/XMLSchema" xmlns:p="http://schemas.microsoft.com/office/2006/metadata/properties" xmlns:ns2="f982cf88-cc58-4d14-9e52-b0a9b43dbd2b" targetNamespace="http://schemas.microsoft.com/office/2006/metadata/properties" ma:root="true" ma:fieldsID="168c62deff5e416130781e8448332a5f" ns2:_="">
     <xsd:import namespace="f982cf88-cc58-4d14-9e52-b0a9b43dbd2b"/>
@@ -57978,6 +58023,15 @@
 </ct:contentTypeSchema>
 </file>
 
+<file path=customXml/item3.xml><?xml version="1.0" encoding="utf-8"?>
+<?mso-contentType ?>
+<FormTemplates xmlns="http://schemas.microsoft.com/sharepoint/v3/contenttype/forms">
+  <Display>DocumentLibraryForm</Display>
+  <Edit>DocumentLibraryForm</Edit>
+  <New>DocumentLibraryForm</New>
+</FormTemplates>
+</file>
+
 <file path=customXml/itemProps1.xml><?xml version="1.0" encoding="utf-8"?>
 <ds:datastoreItem xmlns:ds="http://schemas.openxmlformats.org/officeDocument/2006/customXml" ds:itemID="{DF3BD10E-A445-4B79-8425-7E6BC305B712}">
   <ds:schemaRefs>
@@ -57995,14 +58049,6 @@
 </file>
 
 <file path=customXml/itemProps2.xml><?xml version="1.0" encoding="utf-8"?>
-<ds:datastoreItem xmlns:ds="http://schemas.openxmlformats.org/officeDocument/2006/customXml" ds:itemID="{41E20221-13A7-4721-A09B-C11BA38106B7}">
-  <ds:schemaRefs>
-    <ds:schemaRef ds:uri="http://schemas.microsoft.com/sharepoint/v3/contenttype/forms"/>
-  </ds:schemaRefs>
-</ds:datastoreItem>
-</file>
-
-<file path=customXml/itemProps3.xml><?xml version="1.0" encoding="utf-8"?>
 <ds:datastoreItem xmlns:ds="http://schemas.openxmlformats.org/officeDocument/2006/customXml" ds:itemID="{93D10FE8-49C4-46FB-90B2-2AF7A9A70510}">
   <ds:schemaRefs>
     <ds:schemaRef ds:uri="f982cf88-cc58-4d14-9e52-b0a9b43dbd2b"/>
@@ -58018,4 +58064,12 @@
     <ds:schemaRef ds:uri="http://www.w3.org/2001/XMLSchema"/>
   </ds:schemaRefs>
 </ds:datastoreItem>
+</file>
+
+<file path=customXml/itemProps3.xml><?xml version="1.0" encoding="utf-8"?>
+<ds:datastoreItem xmlns:ds="http://schemas.openxmlformats.org/officeDocument/2006/customXml" ds:itemID="{41E20221-13A7-4721-A09B-C11BA38106B7}">
+  <ds:schemaRefs>
+    <ds:schemaRef ds:uri="http://schemas.microsoft.com/sharepoint/v3/contenttype/forms"/>
+  </ds:schemaRefs>
+</ds:datastoreItem>
 </file>
</xml_diff>